<commit_message>
feat: embed architecture diagram image into PPT slide 6
</commit_message>
<xml_diff>
--- a/Parkinsons_Voice_Companion_Presentation.pptx
+++ b/Parkinsons_Voice_Companion_Presentation.pptx
@@ -7114,1905 +7114,30 @@
           </a:p>
         </p:txBody>
       </p:sp>
-      <p:sp>
-        <p:nvSpPr>
-          <p:cNvPr id="5" name="Rectangle 4"/>
-          <p:cNvSpPr/>
-          <p:nvPr/>
-        </p:nvSpPr>
-        <p:spPr>
-          <a:xfrm>
-            <a:off x="320040" y="1298448"/>
-            <a:ext cx="2377440" cy="658368"/>
-          </a:xfrm>
-          <a:prstGeom prst="rect">
-            <a:avLst/>
-          </a:prstGeom>
-          <a:solidFill>
-            <a:srgbClr val="00E5FF"/>
-          </a:solidFill>
-          <a:ln>
-            <a:noFill/>
-          </a:ln>
-        </p:spPr>
-        <p:style>
-          <a:lnRef idx="1">
-            <a:schemeClr val="accent1"/>
-          </a:lnRef>
-          <a:fillRef idx="3">
-            <a:schemeClr val="accent1"/>
-          </a:fillRef>
-          <a:effectRef idx="2">
-            <a:schemeClr val="accent1"/>
-          </a:effectRef>
-          <a:fontRef idx="minor">
-            <a:schemeClr val="lt1"/>
-          </a:fontRef>
-        </p:style>
-        <p:txBody>
-          <a:bodyPr rtlCol="0" anchor="ctr"/>
-          <a:lstStyle/>
-          <a:p>
-            <a:pPr algn="ctr"/>
-          </a:p>
-        </p:txBody>
-      </p:sp>
-      <p:sp>
-        <p:nvSpPr>
-          <p:cNvPr id="6" name="TextBox 5"/>
-          <p:cNvSpPr txBox="1"/>
-          <p:nvPr/>
-        </p:nvSpPr>
-        <p:spPr>
-          <a:xfrm>
-            <a:off x="320040" y="1298448"/>
-            <a:ext cx="2377440" cy="658368"/>
-          </a:xfrm>
-          <a:prstGeom prst="rect">
-            <a:avLst/>
-          </a:prstGeom>
-          <a:noFill/>
-        </p:spPr>
-        <p:txBody>
-          <a:bodyPr wrap="square">
-            <a:spAutoFit/>
-          </a:bodyPr>
-          <a:lstStyle/>
-          <a:p>
-            <a:pPr algn="ctr"/>
-            <a:r>
-              <a:rPr sz="1250" b="1" i="0">
-                <a:solidFill>
-                  <a:srgbClr val="0A0D14"/>
-                </a:solidFill>
-                <a:latin typeface="Calibri"/>
-              </a:rPr>
-              <a:t>Phase 1
-Preprocessing</a:t>
-            </a:r>
-          </a:p>
-        </p:txBody>
-      </p:sp>
-      <p:sp>
-        <p:nvSpPr>
-          <p:cNvPr id="7" name="Rectangle 6"/>
-          <p:cNvSpPr/>
-          <p:nvPr/>
-        </p:nvSpPr>
-        <p:spPr>
-          <a:xfrm>
-            <a:off x="2926080" y="1298448"/>
-            <a:ext cx="2377440" cy="658368"/>
-          </a:xfrm>
-          <a:prstGeom prst="rect">
-            <a:avLst/>
-          </a:prstGeom>
-          <a:solidFill>
-            <a:srgbClr val="00E676"/>
-          </a:solidFill>
-          <a:ln>
-            <a:noFill/>
-          </a:ln>
-        </p:spPr>
-        <p:style>
-          <a:lnRef idx="1">
-            <a:schemeClr val="accent1"/>
-          </a:lnRef>
-          <a:fillRef idx="3">
-            <a:schemeClr val="accent1"/>
-          </a:fillRef>
-          <a:effectRef idx="2">
-            <a:schemeClr val="accent1"/>
-          </a:effectRef>
-          <a:fontRef idx="minor">
-            <a:schemeClr val="lt1"/>
-          </a:fontRef>
-        </p:style>
-        <p:txBody>
-          <a:bodyPr rtlCol="0" anchor="ctr"/>
-          <a:lstStyle/>
-          <a:p>
-            <a:pPr algn="ctr"/>
-          </a:p>
-        </p:txBody>
-      </p:sp>
-      <p:sp>
-        <p:nvSpPr>
-          <p:cNvPr id="8" name="TextBox 7"/>
-          <p:cNvSpPr txBox="1"/>
-          <p:nvPr/>
-        </p:nvSpPr>
-        <p:spPr>
-          <a:xfrm>
-            <a:off x="2926080" y="1298448"/>
-            <a:ext cx="2377440" cy="658368"/>
-          </a:xfrm>
-          <a:prstGeom prst="rect">
-            <a:avLst/>
-          </a:prstGeom>
-          <a:noFill/>
-        </p:spPr>
-        <p:txBody>
-          <a:bodyPr wrap="square">
-            <a:spAutoFit/>
-          </a:bodyPr>
-          <a:lstStyle/>
-          <a:p>
-            <a:pPr algn="ctr"/>
-            <a:r>
-              <a:rPr sz="1250" b="1" i="0">
-                <a:solidFill>
-                  <a:srgbClr val="0A0D14"/>
-                </a:solidFill>
-                <a:latin typeface="Calibri"/>
-              </a:rPr>
-              <a:t>Phase 2
-DSP Engine</a:t>
-            </a:r>
-          </a:p>
-        </p:txBody>
-      </p:sp>
-      <p:sp>
-        <p:nvSpPr>
-          <p:cNvPr id="9" name="Rectangle 8"/>
-          <p:cNvSpPr/>
-          <p:nvPr/>
-        </p:nvSpPr>
-        <p:spPr>
-          <a:xfrm>
-            <a:off x="5532120" y="1298448"/>
-            <a:ext cx="2377440" cy="658368"/>
-          </a:xfrm>
-          <a:prstGeom prst="rect">
-            <a:avLst/>
-          </a:prstGeom>
-          <a:solidFill>
-            <a:srgbClr val="FFB300"/>
-          </a:solidFill>
-          <a:ln>
-            <a:noFill/>
-          </a:ln>
-        </p:spPr>
-        <p:style>
-          <a:lnRef idx="1">
-            <a:schemeClr val="accent1"/>
-          </a:lnRef>
-          <a:fillRef idx="3">
-            <a:schemeClr val="accent1"/>
-          </a:fillRef>
-          <a:effectRef idx="2">
-            <a:schemeClr val="accent1"/>
-          </a:effectRef>
-          <a:fontRef idx="minor">
-            <a:schemeClr val="lt1"/>
-          </a:fontRef>
-        </p:style>
-        <p:txBody>
-          <a:bodyPr rtlCol="0" anchor="ctr"/>
-          <a:lstStyle/>
-          <a:p>
-            <a:pPr algn="ctr"/>
-          </a:p>
-        </p:txBody>
-      </p:sp>
-      <p:sp>
-        <p:nvSpPr>
-          <p:cNvPr id="10" name="TextBox 9"/>
-          <p:cNvSpPr txBox="1"/>
-          <p:nvPr/>
-        </p:nvSpPr>
-        <p:spPr>
-          <a:xfrm>
-            <a:off x="5532120" y="1298448"/>
-            <a:ext cx="2377440" cy="658368"/>
-          </a:xfrm>
-          <a:prstGeom prst="rect">
-            <a:avLst/>
-          </a:prstGeom>
-          <a:noFill/>
-        </p:spPr>
-        <p:txBody>
-          <a:bodyPr wrap="square">
-            <a:spAutoFit/>
-          </a:bodyPr>
-          <a:lstStyle/>
-          <a:p>
-            <a:pPr algn="ctr"/>
-            <a:r>
-              <a:rPr sz="1250" b="1" i="0">
-                <a:solidFill>
-                  <a:srgbClr val="0A0D14"/>
-                </a:solidFill>
-                <a:latin typeface="Calibri"/>
-              </a:rPr>
-              <a:t>Phase 3
-ML Inference</a:t>
-            </a:r>
-          </a:p>
-        </p:txBody>
-      </p:sp>
-      <p:sp>
-        <p:nvSpPr>
-          <p:cNvPr id="11" name="Rectangle 10"/>
-          <p:cNvSpPr/>
-          <p:nvPr/>
-        </p:nvSpPr>
-        <p:spPr>
-          <a:xfrm>
-            <a:off x="8138160" y="1298448"/>
-            <a:ext cx="2377440" cy="658368"/>
-          </a:xfrm>
-          <a:prstGeom prst="rect">
-            <a:avLst/>
-          </a:prstGeom>
-          <a:solidFill>
-            <a:srgbClr val="9C27B0"/>
-          </a:solidFill>
-          <a:ln>
-            <a:noFill/>
-          </a:ln>
-        </p:spPr>
-        <p:style>
-          <a:lnRef idx="1">
-            <a:schemeClr val="accent1"/>
-          </a:lnRef>
-          <a:fillRef idx="3">
-            <a:schemeClr val="accent1"/>
-          </a:fillRef>
-          <a:effectRef idx="2">
-            <a:schemeClr val="accent1"/>
-          </a:effectRef>
-          <a:fontRef idx="minor">
-            <a:schemeClr val="lt1"/>
-          </a:fontRef>
-        </p:style>
-        <p:txBody>
-          <a:bodyPr rtlCol="0" anchor="ctr"/>
-          <a:lstStyle/>
-          <a:p>
-            <a:pPr algn="ctr"/>
-          </a:p>
-        </p:txBody>
-      </p:sp>
-      <p:sp>
-        <p:nvSpPr>
-          <p:cNvPr id="12" name="TextBox 11"/>
-          <p:cNvSpPr txBox="1"/>
-          <p:nvPr/>
-        </p:nvSpPr>
-        <p:spPr>
-          <a:xfrm>
-            <a:off x="8138160" y="1298448"/>
-            <a:ext cx="2377440" cy="658368"/>
-          </a:xfrm>
-          <a:prstGeom prst="rect">
-            <a:avLst/>
-          </a:prstGeom>
-          <a:noFill/>
-        </p:spPr>
-        <p:txBody>
-          <a:bodyPr wrap="square">
-            <a:spAutoFit/>
-          </a:bodyPr>
-          <a:lstStyle/>
-          <a:p>
-            <a:pPr algn="ctr"/>
-            <a:r>
-              <a:rPr sz="1250" b="1" i="0">
-                <a:solidFill>
-                  <a:srgbClr val="0A0D14"/>
-                </a:solidFill>
-                <a:latin typeface="Calibri"/>
-              </a:rPr>
-              <a:t>Phase 4
-Output Synthesis</a:t>
-            </a:r>
-          </a:p>
-        </p:txBody>
-      </p:sp>
-      <p:sp>
-        <p:nvSpPr>
-          <p:cNvPr id="13" name="Rectangle 12"/>
-          <p:cNvSpPr/>
-          <p:nvPr/>
-        </p:nvSpPr>
-        <p:spPr>
-          <a:xfrm>
-            <a:off x="320040" y="2084831"/>
-            <a:ext cx="2377440" cy="4160520"/>
-          </a:xfrm>
-          <a:prstGeom prst="rect">
-            <a:avLst/>
-          </a:prstGeom>
-          <a:solidFill>
-            <a:srgbClr val="121828"/>
-          </a:solidFill>
-          <a:ln w="12700">
-            <a:solidFill>
-              <a:srgbClr val="9C27B0"/>
-            </a:solidFill>
-          </a:ln>
-        </p:spPr>
-        <p:style>
-          <a:lnRef idx="1">
-            <a:schemeClr val="accent1"/>
-          </a:lnRef>
-          <a:fillRef idx="3">
-            <a:schemeClr val="accent1"/>
-          </a:fillRef>
-          <a:effectRef idx="2">
-            <a:schemeClr val="accent1"/>
-          </a:effectRef>
-          <a:fontRef idx="minor">
-            <a:schemeClr val="lt1"/>
-          </a:fontRef>
-        </p:style>
-        <p:txBody>
-          <a:bodyPr rtlCol="0" anchor="ctr"/>
-          <a:lstStyle/>
-          <a:p>
-            <a:pPr algn="ctr"/>
-          </a:p>
-        </p:txBody>
-      </p:sp>
-      <p:sp>
-        <p:nvSpPr>
-          <p:cNvPr id="14" name="TextBox 13"/>
-          <p:cNvSpPr txBox="1"/>
-          <p:nvPr/>
-        </p:nvSpPr>
-        <p:spPr>
-          <a:xfrm>
-            <a:off x="457200" y="2194559"/>
-            <a:ext cx="2103120" cy="347472"/>
-          </a:xfrm>
-          <a:prstGeom prst="rect">
-            <a:avLst/>
-          </a:prstGeom>
-          <a:noFill/>
-        </p:spPr>
-        <p:txBody>
-          <a:bodyPr wrap="square">
-            <a:spAutoFit/>
-          </a:bodyPr>
-          <a:lstStyle/>
-          <a:p>
-            <a:pPr algn="l"/>
-            <a:r>
-              <a:rPr sz="1300" b="1" i="0">
-                <a:solidFill>
-                  <a:srgbClr val="00E5FF"/>
-                </a:solidFill>
-                <a:latin typeface="Calibri"/>
-              </a:rPr>
-              <a:t>Input &amp; Preprocessing</a:t>
-            </a:r>
-          </a:p>
-        </p:txBody>
-      </p:sp>
-      <p:sp>
-        <p:nvSpPr>
-          <p:cNvPr id="15" name="TextBox 14"/>
-          <p:cNvSpPr txBox="1"/>
-          <p:nvPr/>
-        </p:nvSpPr>
-        <p:spPr>
-          <a:xfrm>
-            <a:off x="457200" y="2542031"/>
-            <a:ext cx="2103120" cy="3611880"/>
-          </a:xfrm>
-          <a:prstGeom prst="rect">
-            <a:avLst/>
-          </a:prstGeom>
-          <a:noFill/>
-        </p:spPr>
-        <p:txBody>
-          <a:bodyPr wrap="square">
-            <a:spAutoFit/>
-          </a:bodyPr>
-          <a:lstStyle/>
-          <a:p>
-            <a:pPr algn="l">
-              <a:spcAft>
-                <a:spcPts val="300"/>
-              </a:spcAft>
-            </a:pPr>
-            <a:r>
-              <a:rPr sz="1150" b="0">
-                <a:solidFill>
-                  <a:srgbClr val="FFFFFF"/>
-                </a:solidFill>
-                <a:latin typeface="Calibri"/>
-              </a:rPr>
-              <a:t>User records 3-5 s</a:t>
-            </a:r>
-          </a:p>
-          <a:p>
-            <a:pPr algn="l">
-              <a:spcAft>
-                <a:spcPts val="300"/>
-              </a:spcAft>
-            </a:pPr>
-            <a:r>
-              <a:rPr sz="1150" b="0">
-                <a:solidFill>
-                  <a:srgbClr val="FFFFFF"/>
-                </a:solidFill>
-                <a:latin typeface="Calibri"/>
-              </a:rPr>
-              <a:t>sustained /a/ vowel</a:t>
-            </a:r>
-          </a:p>
-          <a:p>
-            <a:pPr algn="l">
-              <a:spcAft>
-                <a:spcPts val="300"/>
-              </a:spcAft>
-            </a:pPr>
-            <a:r>
-              <a:rPr sz="1150" b="0">
-                <a:solidFill>
-                  <a:srgbClr val="FFFFFF"/>
-                </a:solidFill>
-                <a:latin typeface="Calibri"/>
-              </a:rPr>
-              <a:t>via Web Audio API</a:t>
-            </a:r>
-          </a:p>
-          <a:p>
-            <a:pPr algn="l">
-              <a:spcAft>
-                <a:spcPts val="300"/>
-              </a:spcAft>
-            </a:pPr>
-            <a:r>
-              <a:rPr sz="1150" b="0">
-                <a:solidFill>
-                  <a:srgbClr val="FFFFFF"/>
-                </a:solidFill>
-                <a:latin typeface="Calibri"/>
-              </a:rPr>
-              <a:t>(44.1 kHz)</a:t>
-            </a:r>
-          </a:p>
-          <a:p>
-            <a:pPr algn="l">
-              <a:spcAft>
-                <a:spcPts val="300"/>
-              </a:spcAft>
-            </a:pPr>
-            <a:r>
-              <a:rPr sz="1150" b="0">
-                <a:solidFill>
-                  <a:srgbClr val="FFFFFF"/>
-                </a:solidFill>
-                <a:latin typeface="Calibri"/>
-              </a:rPr>
-              <a:t>---</a:t>
-            </a:r>
-          </a:p>
-          <a:p>
-            <a:pPr algn="l">
-              <a:spcAft>
-                <a:spcPts val="300"/>
-              </a:spcAft>
-            </a:pPr>
-            <a:r>
-              <a:rPr sz="1150" b="0">
-                <a:solidFill>
-                  <a:srgbClr val="FFFFFF"/>
-                </a:solidFill>
-                <a:latin typeface="Calibri"/>
-              </a:rPr>
-              <a:t>Librosa resample</a:t>
-            </a:r>
-          </a:p>
-          <a:p>
-            <a:pPr algn="l">
-              <a:spcAft>
-                <a:spcPts val="300"/>
-              </a:spcAft>
-            </a:pPr>
-            <a:r>
-              <a:rPr sz="1150" b="0">
-                <a:solidFill>
-                  <a:srgbClr val="FFFFFF"/>
-                </a:solidFill>
-                <a:latin typeface="Calibri"/>
-              </a:rPr>
-              <a:t>-&gt; 22,050 Hz</a:t>
-            </a:r>
-          </a:p>
-          <a:p>
-            <a:pPr algn="l">
-              <a:spcAft>
-                <a:spcPts val="300"/>
-              </a:spcAft>
-            </a:pPr>
-            <a:r>
-              <a:rPr sz="1150" b="0">
-                <a:solidFill>
-                  <a:srgbClr val="FFFFFF"/>
-                </a:solidFill>
-                <a:latin typeface="Calibri"/>
-              </a:rPr>
-              <a:t>Amplitude normalize</a:t>
-            </a:r>
-          </a:p>
-          <a:p>
-            <a:pPr algn="l">
-              <a:spcAft>
-                <a:spcPts val="300"/>
-              </a:spcAft>
-            </a:pPr>
-            <a:r>
-              <a:rPr sz="1150" b="0">
-                <a:solidFill>
-                  <a:srgbClr val="FFFFFF"/>
-                </a:solidFill>
-                <a:latin typeface="Calibri"/>
-              </a:rPr>
-              <a:t>DC offset removal</a:t>
-            </a:r>
-          </a:p>
-        </p:txBody>
-      </p:sp>
-      <p:sp>
-        <p:nvSpPr>
-          <p:cNvPr id="16" name="Rectangle 15"/>
-          <p:cNvSpPr/>
-          <p:nvPr/>
-        </p:nvSpPr>
-        <p:spPr>
-          <a:xfrm>
-            <a:off x="2926080" y="2084831"/>
-            <a:ext cx="2377440" cy="4160520"/>
-          </a:xfrm>
-          <a:prstGeom prst="rect">
-            <a:avLst/>
-          </a:prstGeom>
-          <a:solidFill>
-            <a:srgbClr val="121828"/>
-          </a:solidFill>
-          <a:ln w="12700">
-            <a:solidFill>
-              <a:srgbClr val="9C27B0"/>
-            </a:solidFill>
-          </a:ln>
-        </p:spPr>
-        <p:style>
-          <a:lnRef idx="1">
-            <a:schemeClr val="accent1"/>
-          </a:lnRef>
-          <a:fillRef idx="3">
-            <a:schemeClr val="accent1"/>
-          </a:fillRef>
-          <a:effectRef idx="2">
-            <a:schemeClr val="accent1"/>
-          </a:effectRef>
-          <a:fontRef idx="minor">
-            <a:schemeClr val="lt1"/>
-          </a:fontRef>
-        </p:style>
-        <p:txBody>
-          <a:bodyPr rtlCol="0" anchor="ctr"/>
-          <a:lstStyle/>
-          <a:p>
-            <a:pPr algn="ctr"/>
-          </a:p>
-        </p:txBody>
-      </p:sp>
-      <p:sp>
-        <p:nvSpPr>
-          <p:cNvPr id="17" name="TextBox 16"/>
-          <p:cNvSpPr txBox="1"/>
-          <p:nvPr/>
-        </p:nvSpPr>
-        <p:spPr>
-          <a:xfrm>
-            <a:off x="3063240" y="2194559"/>
-            <a:ext cx="2103120" cy="347472"/>
-          </a:xfrm>
-          <a:prstGeom prst="rect">
-            <a:avLst/>
-          </a:prstGeom>
-          <a:noFill/>
-        </p:spPr>
-        <p:txBody>
-          <a:bodyPr wrap="square">
-            <a:spAutoFit/>
-          </a:bodyPr>
-          <a:lstStyle/>
-          <a:p>
-            <a:pPr algn="l"/>
-            <a:r>
-              <a:rPr sz="1300" b="1" i="0">
-                <a:solidFill>
-                  <a:srgbClr val="00E5FF"/>
-                </a:solidFill>
-                <a:latin typeface="Calibri"/>
-              </a:rPr>
-              <a:t>DSP Feature Engine</a:t>
-            </a:r>
-          </a:p>
-        </p:txBody>
-      </p:sp>
-      <p:sp>
-        <p:nvSpPr>
-          <p:cNvPr id="18" name="TextBox 17"/>
-          <p:cNvSpPr txBox="1"/>
-          <p:nvPr/>
-        </p:nvSpPr>
-        <p:spPr>
-          <a:xfrm>
-            <a:off x="3063240" y="2542031"/>
-            <a:ext cx="2103120" cy="3611880"/>
-          </a:xfrm>
-          <a:prstGeom prst="rect">
-            <a:avLst/>
-          </a:prstGeom>
-          <a:noFill/>
-        </p:spPr>
-        <p:txBody>
-          <a:bodyPr wrap="square">
-            <a:spAutoFit/>
-          </a:bodyPr>
-          <a:lstStyle/>
-          <a:p>
-            <a:pPr algn="l">
-              <a:spcAft>
-                <a:spcPts val="300"/>
-              </a:spcAft>
-            </a:pPr>
-            <a:r>
-              <a:rPr sz="1100" b="0">
-                <a:solidFill>
-                  <a:srgbClr val="FFFFFF"/>
-                </a:solidFill>
-                <a:latin typeface="Calibri"/>
-              </a:rPr>
-              <a:t>Parselmouth (Praat):</a:t>
-            </a:r>
-          </a:p>
-          <a:p>
-            <a:pPr algn="l">
-              <a:spcAft>
-                <a:spcPts val="300"/>
-              </a:spcAft>
-            </a:pPr>
-            <a:r>
-              <a:rPr sz="1100" b="0">
-                <a:solidFill>
-                  <a:srgbClr val="FFFFFF"/>
-                </a:solidFill>
-                <a:latin typeface="Calibri"/>
-              </a:rPr>
-              <a:t>F0 contour</a:t>
-            </a:r>
-          </a:p>
-          <a:p>
-            <a:pPr algn="l">
-              <a:spcAft>
-                <a:spcPts val="300"/>
-              </a:spcAft>
-            </a:pPr>
-            <a:r>
-              <a:rPr sz="1100" b="0">
-                <a:solidFill>
-                  <a:srgbClr val="FFFFFF"/>
-                </a:solidFill>
-                <a:latin typeface="Calibri"/>
-              </a:rPr>
-              <a:t>Jitter (%, Abs, RAP)</a:t>
-            </a:r>
-          </a:p>
-          <a:p>
-            <a:pPr algn="l">
-              <a:spcAft>
-                <a:spcPts val="300"/>
-              </a:spcAft>
-            </a:pPr>
-            <a:r>
-              <a:rPr sz="1100" b="0">
-                <a:solidFill>
-                  <a:srgbClr val="FFFFFF"/>
-                </a:solidFill>
-                <a:latin typeface="Calibri"/>
-              </a:rPr>
-              <a:t>Shimmer (APQ3/5)</a:t>
-            </a:r>
-          </a:p>
-          <a:p>
-            <a:pPr algn="l">
-              <a:spcAft>
-                <a:spcPts val="300"/>
-              </a:spcAft>
-            </a:pPr>
-            <a:r>
-              <a:rPr sz="1100" b="0">
-                <a:solidFill>
-                  <a:srgbClr val="FFFFFF"/>
-                </a:solidFill>
-                <a:latin typeface="Calibri"/>
-              </a:rPr>
-              <a:t>HNR / NHR</a:t>
-            </a:r>
-          </a:p>
-          <a:p>
-            <a:pPr algn="l">
-              <a:spcAft>
-                <a:spcPts val="300"/>
-              </a:spcAft>
-            </a:pPr>
-            <a:r>
-              <a:rPr sz="1100" b="0">
-                <a:solidFill>
-                  <a:srgbClr val="FFFFFF"/>
-                </a:solidFill>
-                <a:latin typeface="Calibri"/>
-              </a:rPr>
-              <a:t/>
-            </a:r>
-          </a:p>
-          <a:p>
-            <a:pPr algn="l">
-              <a:spcAft>
-                <a:spcPts val="300"/>
-              </a:spcAft>
-            </a:pPr>
-            <a:r>
-              <a:rPr sz="1100" b="0">
-                <a:solidFill>
-                  <a:srgbClr val="FFFFFF"/>
-                </a:solidFill>
-                <a:latin typeface="Calibri"/>
-              </a:rPr>
-              <a:t>Non-linear dynamics:</a:t>
-            </a:r>
-          </a:p>
-          <a:p>
-            <a:pPr algn="l">
-              <a:spcAft>
-                <a:spcPts val="300"/>
-              </a:spcAft>
-            </a:pPr>
-            <a:r>
-              <a:rPr sz="1100" b="0">
-                <a:solidFill>
-                  <a:srgbClr val="FFFFFF"/>
-                </a:solidFill>
-                <a:latin typeface="Calibri"/>
-              </a:rPr>
-              <a:t>PPE, RPDE, DFA</a:t>
-            </a:r>
-          </a:p>
-          <a:p>
-            <a:pPr algn="l">
-              <a:spcAft>
-                <a:spcPts val="300"/>
-              </a:spcAft>
-            </a:pPr>
-            <a:r>
-              <a:rPr sz="1100" b="0">
-                <a:solidFill>
-                  <a:srgbClr val="FFFFFF"/>
-                </a:solidFill>
-                <a:latin typeface="Calibri"/>
-              </a:rPr>
-              <a:t>spread1, spread2</a:t>
-            </a:r>
-          </a:p>
-          <a:p>
-            <a:pPr algn="l">
-              <a:spcAft>
-                <a:spcPts val="300"/>
-              </a:spcAft>
-            </a:pPr>
-            <a:r>
-              <a:rPr sz="1100" b="0">
-                <a:solidFill>
-                  <a:srgbClr val="FFFFFF"/>
-                </a:solidFill>
-                <a:latin typeface="Calibri"/>
-              </a:rPr>
-              <a:t/>
-            </a:r>
-          </a:p>
-          <a:p>
-            <a:pPr algn="l">
-              <a:spcAft>
-                <a:spcPts val="300"/>
-              </a:spcAft>
-            </a:pPr>
-            <a:r>
-              <a:rPr sz="1100" b="0">
-                <a:solidFill>
-                  <a:srgbClr val="FFFFFF"/>
-                </a:solidFill>
-                <a:latin typeface="Calibri"/>
-              </a:rPr>
-              <a:t>Output: 22-dim</a:t>
-            </a:r>
-          </a:p>
-          <a:p>
-            <a:pPr algn="l">
-              <a:spcAft>
-                <a:spcPts val="300"/>
-              </a:spcAft>
-            </a:pPr>
-            <a:r>
-              <a:rPr sz="1100" b="0">
-                <a:solidFill>
-                  <a:srgbClr val="FFFFFF"/>
-                </a:solidFill>
-                <a:latin typeface="Calibri"/>
-              </a:rPr>
-              <a:t>feature vector</a:t>
-            </a:r>
-          </a:p>
-        </p:txBody>
-      </p:sp>
-      <p:sp>
-        <p:nvSpPr>
-          <p:cNvPr id="19" name="Rectangle 18"/>
-          <p:cNvSpPr/>
-          <p:nvPr/>
-        </p:nvSpPr>
-        <p:spPr>
-          <a:xfrm>
-            <a:off x="5532120" y="2084831"/>
-            <a:ext cx="2377440" cy="4160520"/>
-          </a:xfrm>
-          <a:prstGeom prst="rect">
-            <a:avLst/>
-          </a:prstGeom>
-          <a:solidFill>
-            <a:srgbClr val="121828"/>
-          </a:solidFill>
-          <a:ln w="12700">
-            <a:solidFill>
-              <a:srgbClr val="9C27B0"/>
-            </a:solidFill>
-          </a:ln>
-        </p:spPr>
-        <p:style>
-          <a:lnRef idx="1">
-            <a:schemeClr val="accent1"/>
-          </a:lnRef>
-          <a:fillRef idx="3">
-            <a:schemeClr val="accent1"/>
-          </a:fillRef>
-          <a:effectRef idx="2">
-            <a:schemeClr val="accent1"/>
-          </a:effectRef>
-          <a:fontRef idx="minor">
-            <a:schemeClr val="lt1"/>
-          </a:fontRef>
-        </p:style>
-        <p:txBody>
-          <a:bodyPr rtlCol="0" anchor="ctr"/>
-          <a:lstStyle/>
-          <a:p>
-            <a:pPr algn="ctr"/>
-          </a:p>
-        </p:txBody>
-      </p:sp>
-      <p:sp>
-        <p:nvSpPr>
-          <p:cNvPr id="20" name="TextBox 19"/>
-          <p:cNvSpPr txBox="1"/>
-          <p:nvPr/>
-        </p:nvSpPr>
-        <p:spPr>
-          <a:xfrm>
-            <a:off x="5669280" y="2194559"/>
-            <a:ext cx="2103120" cy="347472"/>
-          </a:xfrm>
-          <a:prstGeom prst="rect">
-            <a:avLst/>
-          </a:prstGeom>
-          <a:noFill/>
-        </p:spPr>
-        <p:txBody>
-          <a:bodyPr wrap="square">
-            <a:spAutoFit/>
-          </a:bodyPr>
-          <a:lstStyle/>
-          <a:p>
-            <a:pPr algn="l"/>
-            <a:r>
-              <a:rPr sz="1300" b="1" i="0">
-                <a:solidFill>
-                  <a:srgbClr val="00E5FF"/>
-                </a:solidFill>
-                <a:latin typeface="Calibri"/>
-              </a:rPr>
-              <a:t>ML Inference Models</a:t>
-            </a:r>
-          </a:p>
-        </p:txBody>
-      </p:sp>
-      <p:sp>
-        <p:nvSpPr>
-          <p:cNvPr id="21" name="TextBox 20"/>
-          <p:cNvSpPr txBox="1"/>
-          <p:nvPr/>
-        </p:nvSpPr>
-        <p:spPr>
-          <a:xfrm>
-            <a:off x="5669280" y="2542031"/>
-            <a:ext cx="2103120" cy="3611880"/>
-          </a:xfrm>
-          <a:prstGeom prst="rect">
-            <a:avLst/>
-          </a:prstGeom>
-          <a:noFill/>
-        </p:spPr>
-        <p:txBody>
-          <a:bodyPr wrap="square">
-            <a:spAutoFit/>
-          </a:bodyPr>
-          <a:lstStyle/>
-          <a:p>
-            <a:pPr algn="l">
-              <a:spcAft>
-                <a:spcPts val="300"/>
-              </a:spcAft>
-            </a:pPr>
-            <a:r>
-              <a:rPr sz="1100" b="0">
-                <a:solidFill>
-                  <a:srgbClr val="FFFFFF"/>
-                </a:solidFill>
-                <a:latin typeface="Calibri"/>
-              </a:rPr>
-              <a:t>Ensemble Classifiers:</a:t>
-            </a:r>
-          </a:p>
-          <a:p>
-            <a:pPr algn="l">
-              <a:spcAft>
-                <a:spcPts val="300"/>
-              </a:spcAft>
-            </a:pPr>
-            <a:r>
-              <a:rPr sz="1100" b="0">
-                <a:solidFill>
-                  <a:srgbClr val="FFFFFF"/>
-                </a:solidFill>
-                <a:latin typeface="Calibri"/>
-              </a:rPr>
-              <a:t>SVM (RBF kernel)</a:t>
-            </a:r>
-          </a:p>
-          <a:p>
-            <a:pPr algn="l">
-              <a:spcAft>
-                <a:spcPts val="300"/>
-              </a:spcAft>
-            </a:pPr>
-            <a:r>
-              <a:rPr sz="1100" b="0">
-                <a:solidFill>
-                  <a:srgbClr val="FFFFFF"/>
-                </a:solidFill>
-                <a:latin typeface="Calibri"/>
-              </a:rPr>
-              <a:t>Random Forest</a:t>
-            </a:r>
-          </a:p>
-          <a:p>
-            <a:pPr algn="l">
-              <a:spcAft>
-                <a:spcPts val="300"/>
-              </a:spcAft>
-            </a:pPr>
-            <a:r>
-              <a:rPr sz="1100" b="0">
-                <a:solidFill>
-                  <a:srgbClr val="FFFFFF"/>
-                </a:solidFill>
-                <a:latin typeface="Calibri"/>
-              </a:rPr>
-              <a:t>CNN-BiLSTM</a:t>
-            </a:r>
-          </a:p>
-          <a:p>
-            <a:pPr algn="l">
-              <a:spcAft>
-                <a:spcPts val="300"/>
-              </a:spcAft>
-            </a:pPr>
-            <a:r>
-              <a:rPr sz="1100" b="0">
-                <a:solidFill>
-                  <a:srgbClr val="FFFFFF"/>
-                </a:solidFill>
-                <a:latin typeface="Calibri"/>
-              </a:rPr>
-              <a:t>Autoencoder AE</a:t>
-            </a:r>
-          </a:p>
-          <a:p>
-            <a:pPr algn="l">
-              <a:spcAft>
-                <a:spcPts val="300"/>
-              </a:spcAft>
-            </a:pPr>
-            <a:r>
-              <a:rPr sz="1100" b="0">
-                <a:solidFill>
-                  <a:srgbClr val="FFFFFF"/>
-                </a:solidFill>
-                <a:latin typeface="Calibri"/>
-              </a:rPr>
-              <a:t>anomaly z-score</a:t>
-            </a:r>
-          </a:p>
-          <a:p>
-            <a:pPr algn="l">
-              <a:spcAft>
-                <a:spcPts val="300"/>
-              </a:spcAft>
-            </a:pPr>
-            <a:r>
-              <a:rPr sz="1100" b="0">
-                <a:solidFill>
-                  <a:srgbClr val="FFFFFF"/>
-                </a:solidFill>
-                <a:latin typeface="Calibri"/>
-              </a:rPr>
-              <a:t/>
-            </a:r>
-          </a:p>
-          <a:p>
-            <a:pPr algn="l">
-              <a:spcAft>
-                <a:spcPts val="300"/>
-              </a:spcAft>
-            </a:pPr>
-            <a:r>
-              <a:rPr sz="1100" b="0">
-                <a:solidFill>
-                  <a:srgbClr val="FFFFFF"/>
-                </a:solidFill>
-                <a:latin typeface="Calibri"/>
-              </a:rPr>
-              <a:t>Regressors:</a:t>
-            </a:r>
-          </a:p>
-          <a:p>
-            <a:pPr algn="l">
-              <a:spcAft>
-                <a:spcPts val="300"/>
-              </a:spcAft>
-            </a:pPr>
-            <a:r>
-              <a:rPr sz="1100" b="0">
-                <a:solidFill>
-                  <a:srgbClr val="FFFFFF"/>
-                </a:solidFill>
-                <a:latin typeface="Calibri"/>
-              </a:rPr>
-              <a:t>UPDRS Motor RF</a:t>
-            </a:r>
-          </a:p>
-          <a:p>
-            <a:pPr algn="l">
-              <a:spcAft>
-                <a:spcPts val="300"/>
-              </a:spcAft>
-            </a:pPr>
-            <a:r>
-              <a:rPr sz="1100" b="0">
-                <a:solidFill>
-                  <a:srgbClr val="FFFFFF"/>
-                </a:solidFill>
-                <a:latin typeface="Calibri"/>
-              </a:rPr>
-              <a:t>UPDRS Total RF</a:t>
-            </a:r>
-          </a:p>
-          <a:p>
-            <a:pPr algn="l">
-              <a:spcAft>
-                <a:spcPts val="300"/>
-              </a:spcAft>
-            </a:pPr>
-            <a:r>
-              <a:rPr sz="1100" b="0">
-                <a:solidFill>
-                  <a:srgbClr val="FFFFFF"/>
-                </a:solidFill>
-                <a:latin typeface="Calibri"/>
-              </a:rPr>
-              <a:t/>
-            </a:r>
-          </a:p>
-          <a:p>
-            <a:pPr algn="l">
-              <a:spcAft>
-                <a:spcPts val="300"/>
-              </a:spcAft>
-            </a:pPr>
-            <a:r>
-              <a:rPr sz="1100" b="0">
-                <a:solidFill>
-                  <a:srgbClr val="FFFFFF"/>
-                </a:solidFill>
-                <a:latin typeface="Calibri"/>
-              </a:rPr>
-              <a:t>Weights:</a:t>
-            </a:r>
-          </a:p>
-          <a:p>
-            <a:pPr algn="l">
-              <a:spcAft>
-                <a:spcPts val="300"/>
-              </a:spcAft>
-            </a:pPr>
-            <a:r>
-              <a:rPr sz="1100" b="0">
-                <a:solidFill>
-                  <a:srgbClr val="FFFFFF"/>
-                </a:solidFill>
-                <a:latin typeface="Calibri"/>
-              </a:rPr>
-              <a:t>SVM 40% + RF 35%</a:t>
-            </a:r>
-          </a:p>
-          <a:p>
-            <a:pPr algn="l">
-              <a:spcAft>
-                <a:spcPts val="300"/>
-              </a:spcAft>
-            </a:pPr>
-            <a:r>
-              <a:rPr sz="1100" b="0">
-                <a:solidFill>
-                  <a:srgbClr val="FFFFFF"/>
-                </a:solidFill>
-                <a:latin typeface="Calibri"/>
-              </a:rPr>
-              <a:t>+ CNN 25%</a:t>
-            </a:r>
-          </a:p>
-        </p:txBody>
-      </p:sp>
-      <p:sp>
-        <p:nvSpPr>
-          <p:cNvPr id="22" name="Rectangle 21"/>
-          <p:cNvSpPr/>
-          <p:nvPr/>
-        </p:nvSpPr>
-        <p:spPr>
-          <a:xfrm>
-            <a:off x="8138160" y="2084831"/>
-            <a:ext cx="2377440" cy="4160520"/>
-          </a:xfrm>
-          <a:prstGeom prst="rect">
-            <a:avLst/>
-          </a:prstGeom>
-          <a:solidFill>
-            <a:srgbClr val="121828"/>
-          </a:solidFill>
-          <a:ln w="12700">
-            <a:solidFill>
-              <a:srgbClr val="9C27B0"/>
-            </a:solidFill>
-          </a:ln>
-        </p:spPr>
-        <p:style>
-          <a:lnRef idx="1">
-            <a:schemeClr val="accent1"/>
-          </a:lnRef>
-          <a:fillRef idx="3">
-            <a:schemeClr val="accent1"/>
-          </a:fillRef>
-          <a:effectRef idx="2">
-            <a:schemeClr val="accent1"/>
-          </a:effectRef>
-          <a:fontRef idx="minor">
-            <a:schemeClr val="lt1"/>
-          </a:fontRef>
-        </p:style>
-        <p:txBody>
-          <a:bodyPr rtlCol="0" anchor="ctr"/>
-          <a:lstStyle/>
-          <a:p>
-            <a:pPr algn="ctr"/>
-          </a:p>
-        </p:txBody>
-      </p:sp>
-      <p:sp>
-        <p:nvSpPr>
-          <p:cNvPr id="23" name="TextBox 22"/>
-          <p:cNvSpPr txBox="1"/>
-          <p:nvPr/>
-        </p:nvSpPr>
-        <p:spPr>
-          <a:xfrm>
-            <a:off x="8275320" y="2194559"/>
-            <a:ext cx="2103120" cy="347472"/>
-          </a:xfrm>
-          <a:prstGeom prst="rect">
-            <a:avLst/>
-          </a:prstGeom>
-          <a:noFill/>
-        </p:spPr>
-        <p:txBody>
-          <a:bodyPr wrap="square">
-            <a:spAutoFit/>
-          </a:bodyPr>
-          <a:lstStyle/>
-          <a:p>
-            <a:pPr algn="l"/>
-            <a:r>
-              <a:rPr sz="1300" b="1" i="0">
-                <a:solidFill>
-                  <a:srgbClr val="00E5FF"/>
-                </a:solidFill>
-                <a:latin typeface="Calibri"/>
-              </a:rPr>
-              <a:t>Output Dashboard</a:t>
-            </a:r>
-          </a:p>
-        </p:txBody>
-      </p:sp>
-      <p:sp>
-        <p:nvSpPr>
-          <p:cNvPr id="24" name="TextBox 23"/>
-          <p:cNvSpPr txBox="1"/>
-          <p:nvPr/>
-        </p:nvSpPr>
-        <p:spPr>
-          <a:xfrm>
-            <a:off x="8275320" y="2542031"/>
-            <a:ext cx="2103120" cy="3611880"/>
-          </a:xfrm>
-          <a:prstGeom prst="rect">
-            <a:avLst/>
-          </a:prstGeom>
-          <a:noFill/>
-        </p:spPr>
-        <p:txBody>
-          <a:bodyPr wrap="square">
-            <a:spAutoFit/>
-          </a:bodyPr>
-          <a:lstStyle/>
-          <a:p>
-            <a:pPr algn="l">
-              <a:spcAft>
-                <a:spcPts val="300"/>
-              </a:spcAft>
-            </a:pPr>
-            <a:r>
-              <a:rPr sz="1100" b="0">
-                <a:solidFill>
-                  <a:srgbClr val="FFFFFF"/>
-                </a:solidFill>
-                <a:latin typeface="Calibri"/>
-              </a:rPr>
-              <a:t>Ensemble PD Prob %</a:t>
-            </a:r>
-          </a:p>
-          <a:p>
-            <a:pPr algn="l">
-              <a:spcAft>
-                <a:spcPts val="300"/>
-              </a:spcAft>
-            </a:pPr>
-            <a:r>
-              <a:rPr sz="1100" b="0">
-                <a:solidFill>
-                  <a:srgbClr val="FFFFFF"/>
-                </a:solidFill>
-                <a:latin typeface="Calibri"/>
-              </a:rPr>
-              <a:t>Motor-UPDRS score</a:t>
-            </a:r>
-          </a:p>
-          <a:p>
-            <a:pPr algn="l">
-              <a:spcAft>
-                <a:spcPts val="300"/>
-              </a:spcAft>
-            </a:pPr>
-            <a:r>
-              <a:rPr sz="1100" b="0">
-                <a:solidFill>
-                  <a:srgbClr val="FFFFFF"/>
-                </a:solidFill>
-                <a:latin typeface="Calibri"/>
-              </a:rPr>
-              <a:t>Total-UPDRS score</a:t>
-            </a:r>
-          </a:p>
-          <a:p>
-            <a:pPr algn="l">
-              <a:spcAft>
-                <a:spcPts val="300"/>
-              </a:spcAft>
-            </a:pPr>
-            <a:r>
-              <a:rPr sz="1100" b="0">
-                <a:solidFill>
-                  <a:srgbClr val="FFFFFF"/>
-                </a:solidFill>
-                <a:latin typeface="Calibri"/>
-              </a:rPr>
-              <a:t>Anomaly Z-Score</a:t>
-            </a:r>
-          </a:p>
-          <a:p>
-            <a:pPr algn="l">
-              <a:spcAft>
-                <a:spcPts val="300"/>
-              </a:spcAft>
-            </a:pPr>
-            <a:r>
-              <a:rPr sz="1100" b="0">
-                <a:solidFill>
-                  <a:srgbClr val="FFFFFF"/>
-                </a:solidFill>
-                <a:latin typeface="Calibri"/>
-              </a:rPr>
-              <a:t/>
-            </a:r>
-          </a:p>
-          <a:p>
-            <a:pPr algn="l">
-              <a:spcAft>
-                <a:spcPts val="300"/>
-              </a:spcAft>
-            </a:pPr>
-            <a:r>
-              <a:rPr sz="1100" b="0">
-                <a:solidFill>
-                  <a:srgbClr val="FFFFFF"/>
-                </a:solidFill>
-                <a:latin typeface="Calibri"/>
-              </a:rPr>
-              <a:t>Biomarker Radar</a:t>
-            </a:r>
-          </a:p>
-          <a:p>
-            <a:pPr algn="l">
-              <a:spcAft>
-                <a:spcPts val="300"/>
-              </a:spcAft>
-            </a:pPr>
-            <a:r>
-              <a:rPr sz="1100" b="0">
-                <a:solidFill>
-                  <a:srgbClr val="FFFFFF"/>
-                </a:solidFill>
-                <a:latin typeface="Calibri"/>
-              </a:rPr>
-              <a:t>Chart (Chart.js)</a:t>
-            </a:r>
-          </a:p>
-          <a:p>
-            <a:pPr algn="l">
-              <a:spcAft>
-                <a:spcPts val="300"/>
-              </a:spcAft>
-            </a:pPr>
-            <a:r>
-              <a:rPr sz="1100" b="0">
-                <a:solidFill>
-                  <a:srgbClr val="FFFFFF"/>
-                </a:solidFill>
-                <a:latin typeface="Calibri"/>
-              </a:rPr>
-              <a:t/>
-            </a:r>
-          </a:p>
-          <a:p>
-            <a:pPr algn="l">
-              <a:spcAft>
-                <a:spcPts val="300"/>
-              </a:spcAft>
-            </a:pPr>
-            <a:r>
-              <a:rPr sz="1100" b="0">
-                <a:solidFill>
-                  <a:srgbClr val="FFFFFF"/>
-                </a:solidFill>
-                <a:latin typeface="Calibri"/>
-              </a:rPr>
-              <a:t>Longitudinal BOCPD</a:t>
-            </a:r>
-          </a:p>
-          <a:p>
-            <a:pPr algn="l">
-              <a:spcAft>
-                <a:spcPts val="300"/>
-              </a:spcAft>
-            </a:pPr>
-            <a:r>
-              <a:rPr sz="1100" b="0">
-                <a:solidFill>
-                  <a:srgbClr val="FFFFFF"/>
-                </a:solidFill>
-                <a:latin typeface="Calibri"/>
-              </a:rPr>
-              <a:t>Changepoint graph</a:t>
-            </a:r>
-          </a:p>
-          <a:p>
-            <a:pPr algn="l">
-              <a:spcAft>
-                <a:spcPts val="300"/>
-              </a:spcAft>
-            </a:pPr>
-            <a:r>
-              <a:rPr sz="1100" b="0">
-                <a:solidFill>
-                  <a:srgbClr val="FFFFFF"/>
-                </a:solidFill>
-                <a:latin typeface="Calibri"/>
-              </a:rPr>
-              <a:t/>
-            </a:r>
-          </a:p>
-          <a:p>
-            <a:pPr algn="l">
-              <a:spcAft>
-                <a:spcPts val="300"/>
-              </a:spcAft>
-            </a:pPr>
-            <a:r>
-              <a:rPr sz="1100" b="0">
-                <a:solidFill>
-                  <a:srgbClr val="FFFFFF"/>
-                </a:solidFill>
-                <a:latin typeface="Calibri"/>
-              </a:rPr>
-              <a:t>3D Brain Viewer</a:t>
-            </a:r>
-          </a:p>
-          <a:p>
-            <a:pPr algn="l">
-              <a:spcAft>
-                <a:spcPts val="300"/>
-              </a:spcAft>
-            </a:pPr>
-            <a:r>
-              <a:rPr sz="1100" b="0">
-                <a:solidFill>
-                  <a:srgbClr val="FFFFFF"/>
-                </a:solidFill>
-                <a:latin typeface="Calibri"/>
-              </a:rPr>
-              <a:t>(Three.js WebGL)</a:t>
-            </a:r>
-          </a:p>
-        </p:txBody>
-      </p:sp>
-      <p:sp>
-        <p:nvSpPr>
-          <p:cNvPr id="25" name="Rectangle 24"/>
-          <p:cNvSpPr/>
-          <p:nvPr/>
-        </p:nvSpPr>
-        <p:spPr>
-          <a:xfrm>
-            <a:off x="10698480" y="2084831"/>
-            <a:ext cx="1371600" cy="4160520"/>
-          </a:xfrm>
-          <a:prstGeom prst="rect">
-            <a:avLst/>
-          </a:prstGeom>
-          <a:solidFill>
-            <a:srgbClr val="121828"/>
-          </a:solidFill>
-          <a:ln w="12700">
-            <a:solidFill>
-              <a:srgbClr val="9C27B0"/>
-            </a:solidFill>
-          </a:ln>
-        </p:spPr>
-        <p:style>
-          <a:lnRef idx="1">
-            <a:schemeClr val="accent1"/>
-          </a:lnRef>
-          <a:fillRef idx="3">
-            <a:schemeClr val="accent1"/>
-          </a:fillRef>
-          <a:effectRef idx="2">
-            <a:schemeClr val="accent1"/>
-          </a:effectRef>
-          <a:fontRef idx="minor">
-            <a:schemeClr val="lt1"/>
-          </a:fontRef>
-        </p:style>
-        <p:txBody>
-          <a:bodyPr rtlCol="0" anchor="ctr"/>
-          <a:lstStyle/>
-          <a:p>
-            <a:pPr algn="ctr"/>
-          </a:p>
-        </p:txBody>
-      </p:sp>
-      <p:sp>
-        <p:nvSpPr>
-          <p:cNvPr id="26" name="TextBox 25"/>
-          <p:cNvSpPr txBox="1"/>
-          <p:nvPr/>
-        </p:nvSpPr>
-        <p:spPr>
-          <a:xfrm>
-            <a:off x="10835640" y="2194559"/>
-            <a:ext cx="1097280" cy="347472"/>
-          </a:xfrm>
-          <a:prstGeom prst="rect">
-            <a:avLst/>
-          </a:prstGeom>
-          <a:noFill/>
-        </p:spPr>
-        <p:txBody>
-          <a:bodyPr wrap="square">
-            <a:spAutoFit/>
-          </a:bodyPr>
-          <a:lstStyle/>
-          <a:p>
-            <a:pPr algn="l"/>
-            <a:r>
-              <a:rPr sz="1300" b="1" i="0">
-                <a:solidFill>
-                  <a:srgbClr val="00E5FF"/>
-                </a:solidFill>
-                <a:latin typeface="Calibri"/>
-              </a:rPr>
-              <a:t>Frontend</a:t>
-            </a:r>
-          </a:p>
-        </p:txBody>
-      </p:sp>
-      <p:sp>
-        <p:nvSpPr>
-          <p:cNvPr id="27" name="TextBox 26"/>
-          <p:cNvSpPr txBox="1"/>
-          <p:nvPr/>
-        </p:nvSpPr>
-        <p:spPr>
-          <a:xfrm>
-            <a:off x="10835640" y="2542031"/>
-            <a:ext cx="1097280" cy="3611880"/>
-          </a:xfrm>
-          <a:prstGeom prst="rect">
-            <a:avLst/>
-          </a:prstGeom>
-          <a:noFill/>
-        </p:spPr>
-        <p:txBody>
-          <a:bodyPr wrap="square">
-            <a:spAutoFit/>
-          </a:bodyPr>
-          <a:lstStyle/>
-          <a:p>
-            <a:pPr algn="l">
-              <a:spcAft>
-                <a:spcPts val="300"/>
-              </a:spcAft>
-            </a:pPr>
-            <a:r>
-              <a:rPr sz="1100" b="0">
-                <a:solidFill>
-                  <a:srgbClr val="FFFFFF"/>
-                </a:solidFill>
-                <a:latin typeface="Calibri"/>
-              </a:rPr>
-              <a:t>Clinical</a:t>
-            </a:r>
-          </a:p>
-          <a:p>
-            <a:pPr algn="l">
-              <a:spcAft>
-                <a:spcPts val="300"/>
-              </a:spcAft>
-            </a:pPr>
-            <a:r>
-              <a:rPr sz="1100" b="0">
-                <a:solidFill>
-                  <a:srgbClr val="FFFFFF"/>
-                </a:solidFill>
-                <a:latin typeface="Calibri"/>
-              </a:rPr>
-              <a:t>Dashboard</a:t>
-            </a:r>
-          </a:p>
-          <a:p>
-            <a:pPr algn="l">
-              <a:spcAft>
-                <a:spcPts val="300"/>
-              </a:spcAft>
-            </a:pPr>
-            <a:r>
-              <a:rPr sz="1100" b="0">
-                <a:solidFill>
-                  <a:srgbClr val="FFFFFF"/>
-                </a:solidFill>
-                <a:latin typeface="Calibri"/>
-              </a:rPr>
-              <a:t>Radar Charts</a:t>
-            </a:r>
-          </a:p>
-          <a:p>
-            <a:pPr algn="l">
-              <a:spcAft>
-                <a:spcPts val="300"/>
-              </a:spcAft>
-            </a:pPr>
-            <a:r>
-              <a:rPr sz="1100" b="0">
-                <a:solidFill>
-                  <a:srgbClr val="FFFFFF"/>
-                </a:solidFill>
-                <a:latin typeface="Calibri"/>
-              </a:rPr>
-              <a:t>LSVT Coach</a:t>
-            </a:r>
-          </a:p>
-          <a:p>
-            <a:pPr algn="l">
-              <a:spcAft>
-                <a:spcPts val="300"/>
-              </a:spcAft>
-            </a:pPr>
-            <a:r>
-              <a:rPr sz="1100" b="0">
-                <a:solidFill>
-                  <a:srgbClr val="FFFFFF"/>
-                </a:solidFill>
-                <a:latin typeface="Calibri"/>
-              </a:rPr>
-              <a:t>Motor Fusion</a:t>
-            </a:r>
-          </a:p>
-        </p:txBody>
-      </p:sp>
-      <p:sp>
-        <p:nvSpPr>
-          <p:cNvPr id="28" name="TextBox 27"/>
-          <p:cNvSpPr txBox="1"/>
-          <p:nvPr/>
-        </p:nvSpPr>
-        <p:spPr>
-          <a:xfrm>
-            <a:off x="2651760" y="3931920"/>
-            <a:ext cx="457200" cy="274320"/>
-          </a:xfrm>
-          <a:prstGeom prst="rect">
-            <a:avLst/>
-          </a:prstGeom>
-          <a:noFill/>
-        </p:spPr>
-        <p:txBody>
-          <a:bodyPr wrap="square">
-            <a:spAutoFit/>
-          </a:bodyPr>
-          <a:lstStyle/>
-          <a:p>
-            <a:pPr algn="ctr"/>
-            <a:r>
-              <a:rPr sz="1800" b="1" i="0">
-                <a:solidFill>
-                  <a:srgbClr val="9C27B0"/>
-                </a:solidFill>
-                <a:latin typeface="Calibri"/>
-              </a:rPr>
-              <a:t>-&gt;</a:t>
-            </a:r>
-          </a:p>
-        </p:txBody>
-      </p:sp>
-      <p:sp>
-        <p:nvSpPr>
-          <p:cNvPr id="29" name="TextBox 28"/>
-          <p:cNvSpPr txBox="1"/>
-          <p:nvPr/>
-        </p:nvSpPr>
-        <p:spPr>
-          <a:xfrm>
-            <a:off x="5257800" y="3931920"/>
-            <a:ext cx="457200" cy="274320"/>
-          </a:xfrm>
-          <a:prstGeom prst="rect">
-            <a:avLst/>
-          </a:prstGeom>
-          <a:noFill/>
-        </p:spPr>
-        <p:txBody>
-          <a:bodyPr wrap="square">
-            <a:spAutoFit/>
-          </a:bodyPr>
-          <a:lstStyle/>
-          <a:p>
-            <a:pPr algn="ctr"/>
-            <a:r>
-              <a:rPr sz="1800" b="1" i="0">
-                <a:solidFill>
-                  <a:srgbClr val="9C27B0"/>
-                </a:solidFill>
-                <a:latin typeface="Calibri"/>
-              </a:rPr>
-              <a:t>-&gt;</a:t>
-            </a:r>
-          </a:p>
-        </p:txBody>
-      </p:sp>
-      <p:sp>
-        <p:nvSpPr>
-          <p:cNvPr id="30" name="TextBox 29"/>
-          <p:cNvSpPr txBox="1"/>
-          <p:nvPr/>
-        </p:nvSpPr>
-        <p:spPr>
-          <a:xfrm>
-            <a:off x="7863840" y="3931920"/>
-            <a:ext cx="457200" cy="274320"/>
-          </a:xfrm>
-          <a:prstGeom prst="rect">
-            <a:avLst/>
-          </a:prstGeom>
-          <a:noFill/>
-        </p:spPr>
-        <p:txBody>
-          <a:bodyPr wrap="square">
-            <a:spAutoFit/>
-          </a:bodyPr>
-          <a:lstStyle/>
-          <a:p>
-            <a:pPr algn="ctr"/>
-            <a:r>
-              <a:rPr sz="1800" b="1" i="0">
-                <a:solidFill>
-                  <a:srgbClr val="9C27B0"/>
-                </a:solidFill>
-                <a:latin typeface="Calibri"/>
-              </a:rPr>
-              <a:t>-&gt;</a:t>
-            </a:r>
-          </a:p>
-        </p:txBody>
-      </p:sp>
-      <p:sp>
-        <p:nvSpPr>
-          <p:cNvPr id="31" name="TextBox 30"/>
-          <p:cNvSpPr txBox="1"/>
-          <p:nvPr/>
-        </p:nvSpPr>
-        <p:spPr>
-          <a:xfrm>
-            <a:off x="10424160" y="3931920"/>
-            <a:ext cx="457200" cy="274320"/>
-          </a:xfrm>
-          <a:prstGeom prst="rect">
-            <a:avLst/>
-          </a:prstGeom>
-          <a:noFill/>
-        </p:spPr>
-        <p:txBody>
-          <a:bodyPr wrap="square">
-            <a:spAutoFit/>
-          </a:bodyPr>
-          <a:lstStyle/>
-          <a:p>
-            <a:pPr algn="ctr"/>
-            <a:r>
-              <a:rPr sz="1800" b="1" i="0">
-                <a:solidFill>
-                  <a:srgbClr val="9C27B0"/>
-                </a:solidFill>
-                <a:latin typeface="Calibri"/>
-              </a:rPr>
-              <a:t>-&gt;</a:t>
-            </a:r>
-          </a:p>
-        </p:txBody>
-      </p:sp>
-      <p:sp>
-        <p:nvSpPr>
-          <p:cNvPr id="32" name="Rectangle 31"/>
-          <p:cNvSpPr/>
-          <p:nvPr/>
-        </p:nvSpPr>
-        <p:spPr>
-          <a:xfrm>
-            <a:off x="320040" y="6327648"/>
-            <a:ext cx="11548872" cy="384048"/>
-          </a:xfrm>
-          <a:prstGeom prst="rect">
-            <a:avLst/>
-          </a:prstGeom>
-          <a:solidFill>
-            <a:srgbClr val="121828"/>
-          </a:solidFill>
-          <a:ln w="10160">
-            <a:solidFill>
-              <a:srgbClr val="00E5FF"/>
-            </a:solidFill>
-          </a:ln>
-        </p:spPr>
-        <p:style>
-          <a:lnRef idx="1">
-            <a:schemeClr val="accent1"/>
-          </a:lnRef>
-          <a:fillRef idx="3">
-            <a:schemeClr val="accent1"/>
-          </a:fillRef>
-          <a:effectRef idx="2">
-            <a:schemeClr val="accent1"/>
-          </a:effectRef>
-          <a:fontRef idx="minor">
-            <a:schemeClr val="lt1"/>
-          </a:fontRef>
-        </p:style>
-        <p:txBody>
-          <a:bodyPr rtlCol="0" anchor="ctr"/>
-          <a:lstStyle/>
-          <a:p>
-            <a:pPr algn="ctr"/>
-          </a:p>
-        </p:txBody>
-      </p:sp>
-      <p:sp>
-        <p:nvSpPr>
-          <p:cNvPr id="33" name="TextBox 32"/>
-          <p:cNvSpPr txBox="1"/>
-          <p:nvPr/>
-        </p:nvSpPr>
-        <p:spPr>
-          <a:xfrm>
-            <a:off x="457200" y="6364224"/>
-            <a:ext cx="11247120" cy="320040"/>
-          </a:xfrm>
-          <a:prstGeom prst="rect">
-            <a:avLst/>
-          </a:prstGeom>
-          <a:noFill/>
-        </p:spPr>
-        <p:txBody>
-          <a:bodyPr wrap="square">
-            <a:spAutoFit/>
-          </a:bodyPr>
-          <a:lstStyle/>
-          <a:p>
-            <a:pPr algn="ctr"/>
-            <a:r>
-              <a:rPr sz="1150" b="1" i="0">
-                <a:solidFill>
-                  <a:srgbClr val="00E5FF"/>
-                </a:solidFill>
-                <a:latin typeface="Calibri"/>
-              </a:rPr>
-              <a:t>Training Datasets: UCI Oxford (195 recs, 31 subj)  |  UCI Telemonitoring (5,875 recs, 42 subj)  |  Sakar et al. (756 recs, 252 subj)</a:t>
-            </a:r>
-          </a:p>
-        </p:txBody>
-      </p:sp>
+      <p:pic>
+        <p:nvPicPr>
+          <p:cNvPr id="5" name="Picture 4" descr="architecture_diagram_full_1792674967007.jpg"/>
+          <p:cNvPicPr>
+            <a:picLocks noChangeAspect="1"/>
+          </p:cNvPicPr>
+          <p:nvPr/>
+        </p:nvPicPr>
+        <p:blipFill>
+          <a:blip r:embed="rId2"/>
+          <a:stretch>
+            <a:fillRect/>
+          </a:stretch>
+        </p:blipFill>
+        <p:spPr>
+          <a:xfrm>
+            <a:off x="320040" y="1234440"/>
+            <a:ext cx="11548872" cy="5486400"/>
+          </a:xfrm>
+          <a:prstGeom prst="rect">
+            <a:avLst/>
+          </a:prstGeom>
+        </p:spPr>
+      </p:pic>
     </p:spTree>
   </p:cSld>
   <p:clrMapOvr>

</xml_diff>

<commit_message>
docs: add GitHub repository URL to presentation title slide
</commit_message>
<xml_diff>
--- a/Parkinsons_Voice_Companion_Presentation.pptx
+++ b/Parkinsons_Voice_Companion_Presentation.pptx
@@ -3155,7 +3155,7 @@
         </p:nvSpPr>
         <p:spPr>
           <a:xfrm>
-            <a:off x="548640" y="914400"/>
+            <a:off x="548640" y="777240"/>
             <a:ext cx="11064240" cy="1097280"/>
           </a:xfrm>
           <a:prstGeom prst="rect">
@@ -3190,7 +3190,7 @@
         </p:nvSpPr>
         <p:spPr>
           <a:xfrm>
-            <a:off x="914400" y="2057400"/>
+            <a:off x="914400" y="1920240"/>
             <a:ext cx="10332720" cy="640080"/>
           </a:xfrm>
           <a:prstGeom prst="rect">
@@ -3225,7 +3225,7 @@
         </p:nvSpPr>
         <p:spPr>
           <a:xfrm>
-            <a:off x="365760" y="2834640"/>
+            <a:off x="365760" y="2697480"/>
             <a:ext cx="11457432" cy="25400"/>
           </a:xfrm>
           <a:prstGeom prst="rect">
@@ -3268,8 +3268,8 @@
         </p:nvSpPr>
         <p:spPr>
           <a:xfrm>
-            <a:off x="2286000" y="3017520"/>
-            <a:ext cx="7616952" cy="2194560"/>
+            <a:off x="2011680" y="2880360"/>
+            <a:ext cx="8165592" cy="2743200"/>
           </a:xfrm>
           <a:prstGeom prst="rect">
             <a:avLst/>
@@ -3313,8 +3313,8 @@
         </p:nvSpPr>
         <p:spPr>
           <a:xfrm>
-            <a:off x="2560320" y="3154680"/>
-            <a:ext cx="2286000" cy="402336"/>
+            <a:off x="2286000" y="3017520"/>
+            <a:ext cx="2377440" cy="402336"/>
           </a:xfrm>
           <a:prstGeom prst="rect">
             <a:avLst/>
@@ -3329,7 +3329,7 @@
           <a:p>
             <a:pPr algn="l"/>
             <a:r>
-              <a:rPr sz="1500" b="1" i="0">
+              <a:rPr sz="1450" b="1" i="0">
                 <a:solidFill>
                   <a:srgbClr val="00E5FF"/>
                 </a:solidFill>
@@ -3348,8 +3348,8 @@
         </p:nvSpPr>
         <p:spPr>
           <a:xfrm>
-            <a:off x="4846320" y="3154680"/>
-            <a:ext cx="4754880" cy="402336"/>
+            <a:off x="4663440" y="3017520"/>
+            <a:ext cx="5303520" cy="402336"/>
           </a:xfrm>
           <a:prstGeom prst="rect">
             <a:avLst/>
@@ -3364,7 +3364,7 @@
           <a:p>
             <a:pPr algn="l"/>
             <a:r>
-              <a:rPr sz="1500" b="0" i="0">
+              <a:rPr sz="1350" b="0" i="0">
                 <a:solidFill>
                   <a:srgbClr val="FFFFFF"/>
                 </a:solidFill>
@@ -3383,8 +3383,8 @@
         </p:nvSpPr>
         <p:spPr>
           <a:xfrm>
-            <a:off x="2560320" y="3630168"/>
-            <a:ext cx="2286000" cy="402336"/>
+            <a:off x="2286000" y="3511296"/>
+            <a:ext cx="2377440" cy="402336"/>
           </a:xfrm>
           <a:prstGeom prst="rect">
             <a:avLst/>
@@ -3399,7 +3399,7 @@
           <a:p>
             <a:pPr algn="l"/>
             <a:r>
-              <a:rPr sz="1500" b="1" i="0">
+              <a:rPr sz="1450" b="1" i="0">
                 <a:solidFill>
                   <a:srgbClr val="00E5FF"/>
                 </a:solidFill>
@@ -3418,8 +3418,8 @@
         </p:nvSpPr>
         <p:spPr>
           <a:xfrm>
-            <a:off x="4846320" y="3630168"/>
-            <a:ext cx="4754880" cy="402336"/>
+            <a:off x="4663440" y="3511296"/>
+            <a:ext cx="5303520" cy="402336"/>
           </a:xfrm>
           <a:prstGeom prst="rect">
             <a:avLst/>
@@ -3434,7 +3434,7 @@
           <a:p>
             <a:pPr algn="l"/>
             <a:r>
-              <a:rPr sz="1500" b="0" i="0">
+              <a:rPr sz="1350" b="0" i="0">
                 <a:solidFill>
                   <a:srgbClr val="FFFFFF"/>
                 </a:solidFill>
@@ -3453,8 +3453,8 @@
         </p:nvSpPr>
         <p:spPr>
           <a:xfrm>
-            <a:off x="2560320" y="4105656"/>
-            <a:ext cx="2286000" cy="402336"/>
+            <a:off x="2286000" y="4005072"/>
+            <a:ext cx="2377440" cy="402336"/>
           </a:xfrm>
           <a:prstGeom prst="rect">
             <a:avLst/>
@@ -3469,7 +3469,7 @@
           <a:p>
             <a:pPr algn="l"/>
             <a:r>
-              <a:rPr sz="1500" b="1" i="0">
+              <a:rPr sz="1450" b="1" i="0">
                 <a:solidFill>
                   <a:srgbClr val="00E5FF"/>
                 </a:solidFill>
@@ -3488,8 +3488,8 @@
         </p:nvSpPr>
         <p:spPr>
           <a:xfrm>
-            <a:off x="4846320" y="4105656"/>
-            <a:ext cx="4754880" cy="402336"/>
+            <a:off x="4663440" y="4005072"/>
+            <a:ext cx="5303520" cy="402336"/>
           </a:xfrm>
           <a:prstGeom prst="rect">
             <a:avLst/>
@@ -3504,7 +3504,7 @@
           <a:p>
             <a:pPr algn="l"/>
             <a:r>
-              <a:rPr sz="1500" b="0" i="0">
+              <a:rPr sz="1350" b="0" i="0">
                 <a:solidFill>
                   <a:srgbClr val="FFFFFF"/>
                 </a:solidFill>
@@ -3523,8 +3523,8 @@
         </p:nvSpPr>
         <p:spPr>
           <a:xfrm>
-            <a:off x="2560320" y="4581144"/>
-            <a:ext cx="2286000" cy="402336"/>
+            <a:off x="2286000" y="4498848"/>
+            <a:ext cx="2377440" cy="402336"/>
           </a:xfrm>
           <a:prstGeom prst="rect">
             <a:avLst/>
@@ -3539,7 +3539,7 @@
           <a:p>
             <a:pPr algn="l"/>
             <a:r>
-              <a:rPr sz="1500" b="1" i="0">
+              <a:rPr sz="1450" b="1" i="0">
                 <a:solidFill>
                   <a:srgbClr val="00E5FF"/>
                 </a:solidFill>
@@ -3558,8 +3558,8 @@
         </p:nvSpPr>
         <p:spPr>
           <a:xfrm>
-            <a:off x="4846320" y="4581144"/>
-            <a:ext cx="4754880" cy="402336"/>
+            <a:off x="4663440" y="4498848"/>
+            <a:ext cx="5303520" cy="402336"/>
           </a:xfrm>
           <a:prstGeom prst="rect">
             <a:avLst/>
@@ -3574,7 +3574,7 @@
           <a:p>
             <a:pPr algn="l"/>
             <a:r>
-              <a:rPr sz="1500" b="0" i="0">
+              <a:rPr sz="1350" b="0" i="0">
                 <a:solidFill>
                   <a:srgbClr val="FFFFFF"/>
                 </a:solidFill>
@@ -3587,7 +3587,77 @@
       </p:sp>
       <p:sp>
         <p:nvSpPr>
-          <p:cNvPr id="15" name="Rectangle 14"/>
+          <p:cNvPr id="15" name="TextBox 14"/>
+          <p:cNvSpPr txBox="1"/>
+          <p:nvPr/>
+        </p:nvSpPr>
+        <p:spPr>
+          <a:xfrm>
+            <a:off x="2286000" y="4992624"/>
+            <a:ext cx="2377440" cy="402336"/>
+          </a:xfrm>
+          <a:prstGeom prst="rect">
+            <a:avLst/>
+          </a:prstGeom>
+          <a:noFill/>
+        </p:spPr>
+        <p:txBody>
+          <a:bodyPr wrap="square">
+            <a:spAutoFit/>
+          </a:bodyPr>
+          <a:lstStyle/>
+          <a:p>
+            <a:pPr algn="l"/>
+            <a:r>
+              <a:rPr sz="1450" b="1" i="0">
+                <a:solidFill>
+                  <a:srgbClr val="00E5FF"/>
+                </a:solidFill>
+                <a:latin typeface="Calibri"/>
+              </a:rPr>
+              <a:t>GitHub Repository:</a:t>
+            </a:r>
+          </a:p>
+        </p:txBody>
+      </p:sp>
+      <p:sp>
+        <p:nvSpPr>
+          <p:cNvPr id="16" name="TextBox 15"/>
+          <p:cNvSpPr txBox="1"/>
+          <p:nvPr/>
+        </p:nvSpPr>
+        <p:spPr>
+          <a:xfrm>
+            <a:off x="4663440" y="4992624"/>
+            <a:ext cx="5303520" cy="402336"/>
+          </a:xfrm>
+          <a:prstGeom prst="rect">
+            <a:avLst/>
+          </a:prstGeom>
+          <a:noFill/>
+        </p:spPr>
+        <p:txBody>
+          <a:bodyPr wrap="square">
+            <a:spAutoFit/>
+          </a:bodyPr>
+          <a:lstStyle/>
+          <a:p>
+            <a:pPr algn="l"/>
+            <a:r>
+              <a:rPr sz="1350" b="1" i="0">
+                <a:solidFill>
+                  <a:srgbClr val="00D4FF"/>
+                </a:solidFill>
+                <a:latin typeface="Calibri"/>
+              </a:rPr>
+              <a:t>github.com/RaaghavAgarwal28/parkinsons-voice-companion</a:t>
+            </a:r>
+          </a:p>
+        </p:txBody>
+      </p:sp>
+      <p:sp>
+        <p:nvSpPr>
+          <p:cNvPr id="17" name="Rectangle 16"/>
           <p:cNvSpPr/>
           <p:nvPr/>
         </p:nvSpPr>
@@ -3630,13 +3700,13 @@
       </p:sp>
       <p:sp>
         <p:nvSpPr>
-          <p:cNvPr id="16" name="TextBox 15"/>
+          <p:cNvPr id="18" name="TextBox 17"/>
           <p:cNvSpPr txBox="1"/>
           <p:nvPr/>
         </p:nvSpPr>
         <p:spPr>
           <a:xfrm>
-            <a:off x="0" y="6473952"/>
+            <a:off x="0" y="6446520"/>
             <a:ext cx="12188952" cy="274320"/>
           </a:xfrm>
           <a:prstGeom prst="rect">

</xml_diff>